<commit_message>
docs: rapport en prose continue + notes d'orateur (~15 min) dans la présentation
Remplace les listes à puces du rapport par du texte rédigé et ajoute un
script d'orateur sur les 13 diapositives, calé sur une présentation de
15 minutes (hors 5 min de questions).

Co-Authored-By: Claude Opus 4.7 <noreply@anthropic.com>
</commit_message>
<xml_diff>
--- a/Livrables/Presentation_DataCut.pptx
+++ b/Livrables/Presentation_DataCut.pptx
@@ -6,18 +6,18 @@
   </p:sldMasterIdLst>
   <p:sldIdLst>
     <p:sldId id="256" r:id="rId7"/>
-    <p:sldId id="257" r:id="rId8"/>
-    <p:sldId id="258" r:id="rId9"/>
-    <p:sldId id="259" r:id="rId10"/>
-    <p:sldId id="260" r:id="rId11"/>
-    <p:sldId id="261" r:id="rId12"/>
-    <p:sldId id="262" r:id="rId13"/>
-    <p:sldId id="263" r:id="rId14"/>
-    <p:sldId id="264" r:id="rId15"/>
-    <p:sldId id="265" r:id="rId16"/>
-    <p:sldId id="266" r:id="rId17"/>
-    <p:sldId id="267" r:id="rId18"/>
-    <p:sldId id="268" r:id="rId19"/>
+    <p:sldId id="257" r:id="rId9"/>
+    <p:sldId id="258" r:id="rId10"/>
+    <p:sldId id="259" r:id="rId11"/>
+    <p:sldId id="260" r:id="rId12"/>
+    <p:sldId id="261" r:id="rId13"/>
+    <p:sldId id="262" r:id="rId14"/>
+    <p:sldId id="263" r:id="rId15"/>
+    <p:sldId id="264" r:id="rId16"/>
+    <p:sldId id="265" r:id="rId17"/>
+    <p:sldId id="266" r:id="rId18"/>
+    <p:sldId id="267" r:id="rId19"/>
+    <p:sldId id="268" r:id="rId20"/>
   </p:sldIdLst>
   <p:sldSz cx="12188952" cy="6858000" type="screen4x3"/>
   <p:notesSz cx="6858000" cy="9144000"/>
@@ -117,6 +117,1336 @@
     </a:lvl9pPr>
   </p:defaultTextStyle>
 </p:presentation>
+</file>
+
+<file path=ppt/notesMasters/notesMaster1.xml><?xml version="1.0" encoding="utf-8"?>
+<p:notesMaster xmlns:a="http://schemas.openxmlformats.org/drawingml/2006/main" xmlns:p="http://schemas.openxmlformats.org/presentationml/2006/main" xmlns:r="http://schemas.openxmlformats.org/officeDocument/2006/relationships">
+  <p:cSld>
+    <p:bg>
+      <p:bgRef idx="1001">
+        <a:schemeClr val="bg1"/>
+      </p:bgRef>
+    </p:bg>
+    <p:spTree>
+      <p:nvGrpSpPr>
+        <p:cNvPr id="1" name=""/>
+        <p:cNvGrpSpPr/>
+        <p:nvPr/>
+      </p:nvGrpSpPr>
+      <p:grpSpPr>
+        <a:xfrm>
+          <a:off x="0" y="0"/>
+          <a:ext cx="0" cy="0"/>
+          <a:chOff x="0" y="0"/>
+          <a:chExt cx="0" cy="0"/>
+        </a:xfrm>
+      </p:grpSpPr>
+      <p:sp>
+        <p:nvSpPr>
+          <p:cNvPr id="2" name="Header Placeholder 1"/>
+          <p:cNvSpPr>
+            <a:spLocks noGrp="1"/>
+          </p:cNvSpPr>
+          <p:nvPr>
+            <p:ph type="hdr" sz="quarter"/>
+          </p:nvPr>
+        </p:nvSpPr>
+        <p:spPr>
+          <a:xfrm>
+            <a:off x="0" y="0"/>
+            <a:ext cx="2971800" cy="457200"/>
+          </a:xfrm>
+          <a:prstGeom prst="rect">
+            <a:avLst/>
+          </a:prstGeom>
+        </p:spPr>
+        <p:txBody>
+          <a:bodyPr vert="horz" lIns="91440" tIns="45720" rIns="91440" bIns="45720" rtlCol="0"/>
+          <a:lstStyle>
+            <a:lvl1pPr algn="l">
+              <a:defRPr sz="1200"/>
+            </a:lvl1pPr>
+          </a:lstStyle>
+          <a:p>
+            <a:endParaRPr lang="en-US"/>
+          </a:p>
+        </p:txBody>
+      </p:sp>
+      <p:sp>
+        <p:nvSpPr>
+          <p:cNvPr id="3" name="Date Placeholder 2"/>
+          <p:cNvSpPr>
+            <a:spLocks noGrp="1"/>
+          </p:cNvSpPr>
+          <p:nvPr>
+            <p:ph type="dt" idx="1"/>
+          </p:nvPr>
+        </p:nvSpPr>
+        <p:spPr>
+          <a:xfrm>
+            <a:off x="3884613" y="0"/>
+            <a:ext cx="2971800" cy="457200"/>
+          </a:xfrm>
+          <a:prstGeom prst="rect">
+            <a:avLst/>
+          </a:prstGeom>
+        </p:spPr>
+        <p:txBody>
+          <a:bodyPr vert="horz" lIns="91440" tIns="45720" rIns="91440" bIns="45720" rtlCol="0"/>
+          <a:lstStyle>
+            <a:lvl1pPr algn="r">
+              <a:defRPr sz="1200"/>
+            </a:lvl1pPr>
+          </a:lstStyle>
+          <a:p>
+            <a:fld id="{0F89C1C7-3DCD-1040-A9CF-14679D8B5DDD}" type="datetimeFigureOut">
+              <a:rPr lang="en-US" smtClean="0"/>
+              <a:t>10/17/16</a:t>
+            </a:fld>
+            <a:endParaRPr lang="en-US"/>
+          </a:p>
+        </p:txBody>
+      </p:sp>
+      <p:sp>
+        <p:nvSpPr>
+          <p:cNvPr id="4" name="Slide Image Placeholder 3"/>
+          <p:cNvSpPr>
+            <a:spLocks noGrp="1" noRot="1" noChangeAspect="1"/>
+          </p:cNvSpPr>
+          <p:nvPr>
+            <p:ph type="sldImg" idx="2"/>
+          </p:nvPr>
+        </p:nvSpPr>
+        <p:spPr>
+          <a:xfrm>
+            <a:off x="1143000" y="685800"/>
+            <a:ext cx="4572000" cy="3429000"/>
+          </a:xfrm>
+          <a:prstGeom prst="rect">
+            <a:avLst/>
+          </a:prstGeom>
+          <a:noFill/>
+          <a:ln w="12700">
+            <a:solidFill>
+              <a:prstClr val="black"/>
+            </a:solidFill>
+          </a:ln>
+        </p:spPr>
+        <p:txBody>
+          <a:bodyPr vert="horz" lIns="91440" tIns="45720" rIns="91440" bIns="45720" rtlCol="0" anchor="ctr"/>
+          <a:lstStyle/>
+          <a:p>
+            <a:endParaRPr lang="en-US"/>
+          </a:p>
+        </p:txBody>
+      </p:sp>
+      <p:sp>
+        <p:nvSpPr>
+          <p:cNvPr id="5" name="Notes Placeholder 4"/>
+          <p:cNvSpPr>
+            <a:spLocks noGrp="1"/>
+          </p:cNvSpPr>
+          <p:nvPr>
+            <p:ph type="body" sz="quarter" idx="3"/>
+          </p:nvPr>
+        </p:nvSpPr>
+        <p:spPr>
+          <a:xfrm>
+            <a:off x="685800" y="4343400"/>
+            <a:ext cx="5486400" cy="4114800"/>
+          </a:xfrm>
+          <a:prstGeom prst="rect">
+            <a:avLst/>
+          </a:prstGeom>
+        </p:spPr>
+        <p:txBody>
+          <a:bodyPr vert="horz" lIns="91440" tIns="45720" rIns="91440" bIns="45720" rtlCol="0"/>
+          <a:lstStyle/>
+          <a:p>
+            <a:pPr lvl="0"/>
+            <a:r>
+              <a:rPr lang="en-US" smtClean="0"/>
+              <a:t>Click to edit Master text styles</a:t>
+            </a:r>
+          </a:p>
+          <a:p>
+            <a:pPr lvl="1"/>
+            <a:r>
+              <a:rPr lang="en-US" smtClean="0"/>
+              <a:t>Second level</a:t>
+            </a:r>
+          </a:p>
+          <a:p>
+            <a:pPr lvl="2"/>
+            <a:r>
+              <a:rPr lang="en-US" smtClean="0"/>
+              <a:t>Third level</a:t>
+            </a:r>
+          </a:p>
+          <a:p>
+            <a:pPr lvl="3"/>
+            <a:r>
+              <a:rPr lang="en-US" smtClean="0"/>
+              <a:t>Fourth level</a:t>
+            </a:r>
+          </a:p>
+          <a:p>
+            <a:pPr lvl="4"/>
+            <a:r>
+              <a:rPr lang="en-US" smtClean="0"/>
+              <a:t>Fifth level</a:t>
+            </a:r>
+            <a:endParaRPr lang="en-US"/>
+          </a:p>
+        </p:txBody>
+      </p:sp>
+      <p:sp>
+        <p:nvSpPr>
+          <p:cNvPr id="6" name="Footer Placeholder 5"/>
+          <p:cNvSpPr>
+            <a:spLocks noGrp="1"/>
+          </p:cNvSpPr>
+          <p:nvPr>
+            <p:ph type="ftr" sz="quarter" idx="4"/>
+          </p:nvPr>
+        </p:nvSpPr>
+        <p:spPr>
+          <a:xfrm>
+            <a:off x="0" y="8685213"/>
+            <a:ext cx="2971800" cy="457200"/>
+          </a:xfrm>
+          <a:prstGeom prst="rect">
+            <a:avLst/>
+          </a:prstGeom>
+        </p:spPr>
+        <p:txBody>
+          <a:bodyPr vert="horz" lIns="91440" tIns="45720" rIns="91440" bIns="45720" rtlCol="0" anchor="b"/>
+          <a:lstStyle>
+            <a:lvl1pPr algn="l">
+              <a:defRPr sz="1200"/>
+            </a:lvl1pPr>
+          </a:lstStyle>
+          <a:p>
+            <a:endParaRPr lang="en-US"/>
+          </a:p>
+        </p:txBody>
+      </p:sp>
+      <p:sp>
+        <p:nvSpPr>
+          <p:cNvPr id="7" name="Slide Number Placeholder 6"/>
+          <p:cNvSpPr>
+            <a:spLocks noGrp="1"/>
+          </p:cNvSpPr>
+          <p:nvPr>
+            <p:ph type="sldNum" sz="quarter" idx="5"/>
+          </p:nvPr>
+        </p:nvSpPr>
+        <p:spPr>
+          <a:xfrm>
+            <a:off x="3884613" y="8685213"/>
+            <a:ext cx="2971800" cy="457200"/>
+          </a:xfrm>
+          <a:prstGeom prst="rect">
+            <a:avLst/>
+          </a:prstGeom>
+        </p:spPr>
+        <p:txBody>
+          <a:bodyPr vert="horz" lIns="91440" tIns="45720" rIns="91440" bIns="45720" rtlCol="0" anchor="b"/>
+          <a:lstStyle>
+            <a:lvl1pPr algn="r">
+              <a:defRPr sz="1200"/>
+            </a:lvl1pPr>
+          </a:lstStyle>
+          <a:p>
+            <a:fld id="{BB5E49A5-4136-284D-997B-48E1D791AD67}" type="slidenum">
+              <a:rPr lang="en-US" smtClean="0"/>
+              <a:t>‹#›</a:t>
+            </a:fld>
+            <a:endParaRPr lang="en-US"/>
+          </a:p>
+        </p:txBody>
+      </p:sp>
+    </p:spTree>
+    <p:extLst>
+      <p:ext uri="{BB962C8B-B14F-4D97-AF65-F5344CB8AC3E}">
+        <p14:creationId xmlns:p14="http://schemas.microsoft.com/office/powerpoint/2010/main" val="2623252185"/>
+      </p:ext>
+    </p:extLst>
+  </p:cSld>
+  <p:clrMap bg1="lt1" tx1="dk1" bg2="lt2" tx2="dk2" accent1="accent1" accent2="accent2" accent3="accent3" accent4="accent4" accent5="accent5" accent6="accent6" hlink="hlink" folHlink="folHlink"/>
+  <p:notesStyle>
+    <a:lvl1pPr marL="0" algn="l" defTabSz="457200" rtl="0" eaLnBrk="1" latinLnBrk="0" hangingPunct="1">
+      <a:defRPr sz="1200" kern="1200">
+        <a:solidFill>
+          <a:schemeClr val="tx1"/>
+        </a:solidFill>
+        <a:latin typeface="+mn-lt"/>
+        <a:ea typeface="+mn-ea"/>
+        <a:cs typeface="+mn-cs"/>
+      </a:defRPr>
+    </a:lvl1pPr>
+    <a:lvl2pPr marL="457200" algn="l" defTabSz="457200" rtl="0" eaLnBrk="1" latinLnBrk="0" hangingPunct="1">
+      <a:defRPr sz="1200" kern="1200">
+        <a:solidFill>
+          <a:schemeClr val="tx1"/>
+        </a:solidFill>
+        <a:latin typeface="+mn-lt"/>
+        <a:ea typeface="+mn-ea"/>
+        <a:cs typeface="+mn-cs"/>
+      </a:defRPr>
+    </a:lvl2pPr>
+    <a:lvl3pPr marL="914400" algn="l" defTabSz="457200" rtl="0" eaLnBrk="1" latinLnBrk="0" hangingPunct="1">
+      <a:defRPr sz="1200" kern="1200">
+        <a:solidFill>
+          <a:schemeClr val="tx1"/>
+        </a:solidFill>
+        <a:latin typeface="+mn-lt"/>
+        <a:ea typeface="+mn-ea"/>
+        <a:cs typeface="+mn-cs"/>
+      </a:defRPr>
+    </a:lvl3pPr>
+    <a:lvl4pPr marL="1371600" algn="l" defTabSz="457200" rtl="0" eaLnBrk="1" latinLnBrk="0" hangingPunct="1">
+      <a:defRPr sz="1200" kern="1200">
+        <a:solidFill>
+          <a:schemeClr val="tx1"/>
+        </a:solidFill>
+        <a:latin typeface="+mn-lt"/>
+        <a:ea typeface="+mn-ea"/>
+        <a:cs typeface="+mn-cs"/>
+      </a:defRPr>
+    </a:lvl4pPr>
+    <a:lvl5pPr marL="1828800" algn="l" defTabSz="457200" rtl="0" eaLnBrk="1" latinLnBrk="0" hangingPunct="1">
+      <a:defRPr sz="1200" kern="1200">
+        <a:solidFill>
+          <a:schemeClr val="tx1"/>
+        </a:solidFill>
+        <a:latin typeface="+mn-lt"/>
+        <a:ea typeface="+mn-ea"/>
+        <a:cs typeface="+mn-cs"/>
+      </a:defRPr>
+    </a:lvl5pPr>
+    <a:lvl6pPr marL="2286000" algn="l" defTabSz="457200" rtl="0" eaLnBrk="1" latinLnBrk="0" hangingPunct="1">
+      <a:defRPr sz="1200" kern="1200">
+        <a:solidFill>
+          <a:schemeClr val="tx1"/>
+        </a:solidFill>
+        <a:latin typeface="+mn-lt"/>
+        <a:ea typeface="+mn-ea"/>
+        <a:cs typeface="+mn-cs"/>
+      </a:defRPr>
+    </a:lvl6pPr>
+    <a:lvl7pPr marL="2743200" algn="l" defTabSz="457200" rtl="0" eaLnBrk="1" latinLnBrk="0" hangingPunct="1">
+      <a:defRPr sz="1200" kern="1200">
+        <a:solidFill>
+          <a:schemeClr val="tx1"/>
+        </a:solidFill>
+        <a:latin typeface="+mn-lt"/>
+        <a:ea typeface="+mn-ea"/>
+        <a:cs typeface="+mn-cs"/>
+      </a:defRPr>
+    </a:lvl7pPr>
+    <a:lvl8pPr marL="3200400" algn="l" defTabSz="457200" rtl="0" eaLnBrk="1" latinLnBrk="0" hangingPunct="1">
+      <a:defRPr sz="1200" kern="1200">
+        <a:solidFill>
+          <a:schemeClr val="tx1"/>
+        </a:solidFill>
+        <a:latin typeface="+mn-lt"/>
+        <a:ea typeface="+mn-ea"/>
+        <a:cs typeface="+mn-cs"/>
+      </a:defRPr>
+    </a:lvl8pPr>
+    <a:lvl9pPr marL="3657600" algn="l" defTabSz="457200" rtl="0" eaLnBrk="1" latinLnBrk="0" hangingPunct="1">
+      <a:defRPr sz="1200" kern="1200">
+        <a:solidFill>
+          <a:schemeClr val="tx1"/>
+        </a:solidFill>
+        <a:latin typeface="+mn-lt"/>
+        <a:ea typeface="+mn-ea"/>
+        <a:cs typeface="+mn-cs"/>
+      </a:defRPr>
+    </a:lvl9pPr>
+  </p:notesStyle>
+</p:notesMaster>
+</file>
+
+<file path=ppt/notesSlides/notesSlide1.xml><?xml version="1.0" encoding="utf-8"?>
+<p:notes xmlns:a="http://schemas.openxmlformats.org/drawingml/2006/main" xmlns:p="http://schemas.openxmlformats.org/presentationml/2006/main" xmlns:r="http://schemas.openxmlformats.org/officeDocument/2006/relationships">
+  <p:cSld>
+    <p:spTree>
+      <p:nvGrpSpPr>
+        <p:cNvPr id="1" name=""/>
+        <p:cNvGrpSpPr/>
+        <p:nvPr/>
+      </p:nvGrpSpPr>
+      <p:grpSpPr>
+        <a:xfrm>
+          <a:off x="0" y="0"/>
+          <a:ext cx="0" cy="0"/>
+          <a:chOff x="0" y="0"/>
+          <a:chExt cx="0" cy="0"/>
+        </a:xfrm>
+      </p:grpSpPr>
+      <p:sp>
+        <p:nvSpPr>
+          <p:cNvPr id="2" name="Slide Image Placeholder 1"/>
+          <p:cNvSpPr>
+            <a:spLocks noGrp="1"/>
+          </p:cNvSpPr>
+          <p:nvPr>
+            <p:ph type="sldImg" idx="2"/>
+          </p:nvPr>
+        </p:nvSpPr>
+        <p:spPr/>
+      </p:sp>
+      <p:sp>
+        <p:nvSpPr>
+          <p:cNvPr id="3" name="Notes Placeholder 2"/>
+          <p:cNvSpPr>
+            <a:spLocks noGrp="1"/>
+          </p:cNvSpPr>
+          <p:nvPr>
+            <p:ph type="body" idx="3" sz="quarter"/>
+          </p:nvPr>
+        </p:nvSpPr>
+        <p:spPr/>
+        <p:txBody>
+          <a:bodyPr/>
+          <a:lstStyle/>
+          <a:p>
+            <a:r>
+              <a:t>[~30 s] Bonjour à toutes et à tous. Je m'appelle Amaury Guindon et je vais vous présenter mon projet fil rouge de Master 1 Intelligence Artificielle : DataCut, « Symphonie des données en flux continu ». L'idée de ce projet est de construire une plateforme qui gère le cycle de vie complet des données, depuis l'ingestion d'images jusqu'à l'entraînement d'un modèle d'IA. Je vais vous présenter l'architecture, le pipeline de données, la partie machine learning, puis une démonstration de recommandation client. Comptez une quinzaine de minutes, et je garderai du temps pour vos questions à la fin.</a:t>
+            </a:r>
+          </a:p>
+        </p:txBody>
+      </p:sp>
+      <p:sp>
+        <p:nvSpPr>
+          <p:cNvPr id="4" name="Slide Number Placeholder 3"/>
+          <p:cNvSpPr>
+            <a:spLocks noGrp="1"/>
+          </p:cNvSpPr>
+          <p:nvPr>
+            <p:ph type="sldNum" idx="5" sz="quarter"/>
+          </p:nvPr>
+        </p:nvSpPr>
+        <p:spPr/>
+      </p:sp>
+    </p:spTree>
+  </p:cSld>
+  <p:clrMapOvr>
+    <a:masterClrMapping/>
+  </p:clrMapOvr>
+</p:notes>
+</file>
+
+<file path=ppt/notesSlides/notesSlide10.xml><?xml version="1.0" encoding="utf-8"?>
+<p:notes xmlns:a="http://schemas.openxmlformats.org/drawingml/2006/main" xmlns:p="http://schemas.openxmlformats.org/presentationml/2006/main" xmlns:r="http://schemas.openxmlformats.org/officeDocument/2006/relationships">
+  <p:cSld>
+    <p:spTree>
+      <p:nvGrpSpPr>
+        <p:cNvPr id="1" name=""/>
+        <p:cNvGrpSpPr/>
+        <p:nvPr/>
+      </p:nvGrpSpPr>
+      <p:grpSpPr>
+        <a:xfrm>
+          <a:off x="0" y="0"/>
+          <a:ext cx="0" cy="0"/>
+          <a:chOff x="0" y="0"/>
+          <a:chExt cx="0" cy="0"/>
+        </a:xfrm>
+      </p:grpSpPr>
+      <p:sp>
+        <p:nvSpPr>
+          <p:cNvPr id="2" name="Slide Image Placeholder 1"/>
+          <p:cNvSpPr>
+            <a:spLocks noGrp="1"/>
+          </p:cNvSpPr>
+          <p:nvPr>
+            <p:ph type="sldImg" idx="2"/>
+          </p:nvPr>
+        </p:nvSpPr>
+        <p:spPr/>
+      </p:sp>
+      <p:sp>
+        <p:nvSpPr>
+          <p:cNvPr id="3" name="Notes Placeholder 2"/>
+          <p:cNvSpPr>
+            <a:spLocks noGrp="1"/>
+          </p:cNvSpPr>
+          <p:nvPr>
+            <p:ph type="body" idx="3" sz="quarter"/>
+          </p:nvPr>
+        </p:nvSpPr>
+        <p:spPr/>
+        <p:txBody>
+          <a:bodyPr/>
+          <a:lstStyle/>
+          <a:p>
+            <a:r>
+              <a:t>[~1 min] Parlons des résultats et, en toute honnêteté, des limites. Le graphique à gauche montre la distribution réelle des labels sur le dataset version 1. On voit immédiatement un déséquilibre : certains labels comme « après » ou « adulte » sont très présents, tandis que d'autres comme « enfant » ou « rasage » n'apparaissent qu'une fois. C'est un indicateur clé de la qualité d'un dataset.</a:t>
+            </a:r>
+          </a:p>
+          <a:p>
+            <a:r>
+              <a:t>Le modèle génère des métriques classiques : l'accuracy, ainsi que la precision, le recall et le F1-score par label. Mais il faut être lucide : ce dataset est un prototype de neuf images seulement. Les performances chiffrées sont donc forcément limitées, ce n'est pas le but à ce stade. Le point fort, c'est que l'architecture est entièrement scalable : pour améliorer le modèle, il suffit d'ajouter des données et de créer une nouvelle version, sans modifier une seule ligne de code. Plus de données, c'est mécaniquement un meilleur modèle.</a:t>
+            </a:r>
+          </a:p>
+        </p:txBody>
+      </p:sp>
+      <p:sp>
+        <p:nvSpPr>
+          <p:cNvPr id="4" name="Slide Number Placeholder 3"/>
+          <p:cNvSpPr>
+            <a:spLocks noGrp="1"/>
+          </p:cNvSpPr>
+          <p:nvPr>
+            <p:ph type="sldNum" idx="5" sz="quarter"/>
+          </p:nvPr>
+        </p:nvSpPr>
+        <p:spPr/>
+      </p:sp>
+    </p:spTree>
+  </p:cSld>
+  <p:clrMapOvr>
+    <a:masterClrMapping/>
+  </p:clrMapOvr>
+</p:notes>
+</file>
+
+<file path=ppt/notesSlides/notesSlide11.xml><?xml version="1.0" encoding="utf-8"?>
+<p:notes xmlns:a="http://schemas.openxmlformats.org/drawingml/2006/main" xmlns:p="http://schemas.openxmlformats.org/presentationml/2006/main" xmlns:r="http://schemas.openxmlformats.org/officeDocument/2006/relationships">
+  <p:cSld>
+    <p:spTree>
+      <p:nvGrpSpPr>
+        <p:cNvPr id="1" name=""/>
+        <p:cNvGrpSpPr/>
+        <p:nvPr/>
+      </p:nvGrpSpPr>
+      <p:grpSpPr>
+        <a:xfrm>
+          <a:off x="0" y="0"/>
+          <a:ext cx="0" cy="0"/>
+          <a:chOff x="0" y="0"/>
+          <a:chExt cx="0" cy="0"/>
+        </a:xfrm>
+      </p:grpSpPr>
+      <p:sp>
+        <p:nvSpPr>
+          <p:cNvPr id="2" name="Slide Image Placeholder 1"/>
+          <p:cNvSpPr>
+            <a:spLocks noGrp="1"/>
+          </p:cNvSpPr>
+          <p:nvPr>
+            <p:ph type="sldImg" idx="2"/>
+          </p:nvPr>
+        </p:nvSpPr>
+        <p:spPr/>
+      </p:sp>
+      <p:sp>
+        <p:nvSpPr>
+          <p:cNvPr id="3" name="Notes Placeholder 2"/>
+          <p:cNvSpPr>
+            <a:spLocks noGrp="1"/>
+          </p:cNvSpPr>
+          <p:nvPr>
+            <p:ph type="body" idx="3" sz="quarter"/>
+          </p:nvPr>
+        </p:nvSpPr>
+        <p:spPr/>
+        <p:txBody>
+          <a:bodyPr/>
+          <a:lstStyle/>
+          <a:p>
+            <a:r>
+              <a:t>[~1 min 30] Voici maintenant la partie côté client, la page « Ma Coupe Idéale ». C'est une fonctionnalité bonus, mais qui illustre bien un second usage de l'IA. Le client prend une photo, ou en charge une. MediaPipe, qui tourne entièrement dans le navigateur, détecte 468 points de repère sur le visage. À partir de ces points, on calcule la forme du visage et la teinte de peau, puis on propose des styles adaptés et on filtre la galerie en conséquence.</a:t>
+            </a:r>
+          </a:p>
+          <a:p>
+            <a:r>
+              <a:t>Concrètement, pour la forme : un visage ovale est polyvalent, un visage rond ira bien avec un fade ou un taper, un visage carré avec un burst-fade, et ainsi de suite. Pour la teinte de peau, qui donne une indication sur la texture de cheveux, on adapte aussi les suggestions. Le point que je veux vraiment souligner ici, c'est que tout ce traitement se fait localement, dans le navigateur, en WebAssembly. Aucune image, aucune donnée biométrique du visage n'est envoyée à un serveur. C'est une démarche de respect de la vie privée dès la conception, ce qu'on appelle le privacy by design, et c'est essentiel quand on manipule des données aussi sensibles qu'un visage.</a:t>
+            </a:r>
+          </a:p>
+        </p:txBody>
+      </p:sp>
+      <p:sp>
+        <p:nvSpPr>
+          <p:cNvPr id="4" name="Slide Number Placeholder 3"/>
+          <p:cNvSpPr>
+            <a:spLocks noGrp="1"/>
+          </p:cNvSpPr>
+          <p:nvPr>
+            <p:ph type="sldNum" idx="5" sz="quarter"/>
+          </p:nvPr>
+        </p:nvSpPr>
+        <p:spPr/>
+      </p:sp>
+    </p:spTree>
+  </p:cSld>
+  <p:clrMapOvr>
+    <a:masterClrMapping/>
+  </p:clrMapOvr>
+</p:notes>
+</file>
+
+<file path=ppt/notesSlides/notesSlide12.xml><?xml version="1.0" encoding="utf-8"?>
+<p:notes xmlns:a="http://schemas.openxmlformats.org/drawingml/2006/main" xmlns:p="http://schemas.openxmlformats.org/presentationml/2006/main" xmlns:r="http://schemas.openxmlformats.org/officeDocument/2006/relationships">
+  <p:cSld>
+    <p:spTree>
+      <p:nvGrpSpPr>
+        <p:cNvPr id="1" name=""/>
+        <p:cNvGrpSpPr/>
+        <p:nvPr/>
+      </p:nvGrpSpPr>
+      <p:grpSpPr>
+        <a:xfrm>
+          <a:off x="0" y="0"/>
+          <a:ext cx="0" cy="0"/>
+          <a:chOff x="0" y="0"/>
+          <a:chExt cx="0" cy="0"/>
+        </a:xfrm>
+      </p:grpSpPr>
+      <p:sp>
+        <p:nvSpPr>
+          <p:cNvPr id="2" name="Slide Image Placeholder 1"/>
+          <p:cNvSpPr>
+            <a:spLocks noGrp="1"/>
+          </p:cNvSpPr>
+          <p:nvPr>
+            <p:ph type="sldImg" idx="2"/>
+          </p:nvPr>
+        </p:nvSpPr>
+        <p:spPr/>
+      </p:sp>
+      <p:sp>
+        <p:nvSpPr>
+          <p:cNvPr id="3" name="Notes Placeholder 2"/>
+          <p:cNvSpPr>
+            <a:spLocks noGrp="1"/>
+          </p:cNvSpPr>
+          <p:nvPr>
+            <p:ph type="body" idx="3" sz="quarter"/>
+          </p:nvPr>
+        </p:nvSpPr>
+        <p:spPr/>
+        <p:txBody>
+          <a:bodyPr/>
+          <a:lstStyle/>
+          <a:p>
+            <a:r>
+              <a:t>[~1 min] Avant de conclure, un mot sur les bonnes pratiques et la gouvernance des données, car c'est ce qui distingue un projet jouet d'un projet sérieux. Premièrement, la séparation fichiers et métadonnées, dont j'ai parlé : elle rend possible une migration vers le cloud, S3 ou un CDN, sans toucher à la base. Deuxièmement, le versioning immuable, qui assure reproductibilité et auditabilité.</a:t>
+            </a:r>
+          </a:p>
+          <a:p>
+            <a:r>
+              <a:t>Troisièmement, la sécurité : authentification par JWT, connexion Google en OAuth2, gestion des rôles client et admin, et des Guards NestJS sur toutes les routes sensibles. Et quatrièmement, la protection des données personnelles avec MediaPipe en local, dans une logique RGPD. Ces quatre piliers garantissent que la plateforme est non seulement fonctionnelle, mais aussi maintenable, sûre et conforme.</a:t>
+            </a:r>
+          </a:p>
+        </p:txBody>
+      </p:sp>
+      <p:sp>
+        <p:nvSpPr>
+          <p:cNvPr id="4" name="Slide Number Placeholder 3"/>
+          <p:cNvSpPr>
+            <a:spLocks noGrp="1"/>
+          </p:cNvSpPr>
+          <p:nvPr>
+            <p:ph type="sldNum" idx="5" sz="quarter"/>
+          </p:nvPr>
+        </p:nvSpPr>
+        <p:spPr/>
+      </p:sp>
+    </p:spTree>
+  </p:cSld>
+  <p:clrMapOvr>
+    <a:masterClrMapping/>
+  </p:clrMapOvr>
+</p:notes>
+</file>
+
+<file path=ppt/notesSlides/notesSlide13.xml><?xml version="1.0" encoding="utf-8"?>
+<p:notes xmlns:a="http://schemas.openxmlformats.org/drawingml/2006/main" xmlns:p="http://schemas.openxmlformats.org/presentationml/2006/main" xmlns:r="http://schemas.openxmlformats.org/officeDocument/2006/relationships">
+  <p:cSld>
+    <p:spTree>
+      <p:nvGrpSpPr>
+        <p:cNvPr id="1" name=""/>
+        <p:cNvGrpSpPr/>
+        <p:nvPr/>
+      </p:nvGrpSpPr>
+      <p:grpSpPr>
+        <a:xfrm>
+          <a:off x="0" y="0"/>
+          <a:ext cx="0" cy="0"/>
+          <a:chOff x="0" y="0"/>
+          <a:chExt cx="0" cy="0"/>
+        </a:xfrm>
+      </p:grpSpPr>
+      <p:sp>
+        <p:nvSpPr>
+          <p:cNvPr id="2" name="Slide Image Placeholder 1"/>
+          <p:cNvSpPr>
+            <a:spLocks noGrp="1"/>
+          </p:cNvSpPr>
+          <p:nvPr>
+            <p:ph type="sldImg" idx="2"/>
+          </p:nvPr>
+        </p:nvSpPr>
+        <p:spPr/>
+      </p:sp>
+      <p:sp>
+        <p:nvSpPr>
+          <p:cNvPr id="3" name="Notes Placeholder 2"/>
+          <p:cNvSpPr>
+            <a:spLocks noGrp="1"/>
+          </p:cNvSpPr>
+          <p:nvPr>
+            <p:ph type="body" idx="3" sz="quarter"/>
+          </p:nvPr>
+        </p:nvSpPr>
+        <p:spPr/>
+        <p:txBody>
+          <a:bodyPr/>
+          <a:lstStyle/>
+          <a:p>
+            <a:r>
+              <a:t>[~1 min] Pour conclure. Ce projet met en œuvre un cycle de vie complet de la donnée : un pipeline structuré en cinq statuts, une extraction de features automatique, un versioning immuable des datasets, un entraînement ML produisant un modèle réutilisable, une couche de visualisation et de supervision, et même une recommandation client par IA en bonus. Toutes les exigences du sujet sont couvertes.</a:t>
+            </a:r>
+          </a:p>
+          <a:p>
+            <a:r>
+              <a:t>Les perspectives sont claires : constituer un dataset bien plus volumineux, viser une centaine d'images par label, passer à un stockage cloud, exposer le modèle via une API de prédiction en temps réel, automatiser le réentraînement, et à terme remplacer le RandomForest par un réseau de neurones convolutif. Le message que je veux laisser, c'est que l'architecture est scalable par conception : plus on apporte de données, meilleur sera le modèle, et cela sans avoir à modifier le code. Je vous remercie de votre attention, et je suis à votre disposition pour vos questions.</a:t>
+            </a:r>
+          </a:p>
+        </p:txBody>
+      </p:sp>
+      <p:sp>
+        <p:nvSpPr>
+          <p:cNvPr id="4" name="Slide Number Placeholder 3"/>
+          <p:cNvSpPr>
+            <a:spLocks noGrp="1"/>
+          </p:cNvSpPr>
+          <p:nvPr>
+            <p:ph type="sldNum" idx="5" sz="quarter"/>
+          </p:nvPr>
+        </p:nvSpPr>
+        <p:spPr/>
+      </p:sp>
+    </p:spTree>
+  </p:cSld>
+  <p:clrMapOvr>
+    <a:masterClrMapping/>
+  </p:clrMapOvr>
+</p:notes>
+</file>
+
+<file path=ppt/notesSlides/notesSlide2.xml><?xml version="1.0" encoding="utf-8"?>
+<p:notes xmlns:a="http://schemas.openxmlformats.org/drawingml/2006/main" xmlns:p="http://schemas.openxmlformats.org/presentationml/2006/main" xmlns:r="http://schemas.openxmlformats.org/officeDocument/2006/relationships">
+  <p:cSld>
+    <p:spTree>
+      <p:nvGrpSpPr>
+        <p:cNvPr id="1" name=""/>
+        <p:cNvGrpSpPr/>
+        <p:nvPr/>
+      </p:nvGrpSpPr>
+      <p:grpSpPr>
+        <a:xfrm>
+          <a:off x="0" y="0"/>
+          <a:ext cx="0" cy="0"/>
+          <a:chOff x="0" y="0"/>
+          <a:chExt cx="0" cy="0"/>
+        </a:xfrm>
+      </p:grpSpPr>
+      <p:sp>
+        <p:nvSpPr>
+          <p:cNvPr id="2" name="Slide Image Placeholder 1"/>
+          <p:cNvSpPr>
+            <a:spLocks noGrp="1"/>
+          </p:cNvSpPr>
+          <p:nvPr>
+            <p:ph type="sldImg" idx="2"/>
+          </p:nvPr>
+        </p:nvSpPr>
+        <p:spPr/>
+      </p:sp>
+      <p:sp>
+        <p:nvSpPr>
+          <p:cNvPr id="3" name="Notes Placeholder 2"/>
+          <p:cNvSpPr>
+            <a:spLocks noGrp="1"/>
+          </p:cNvSpPr>
+          <p:nvPr>
+            <p:ph type="body" idx="3" sz="quarter"/>
+          </p:nvPr>
+        </p:nvSpPr>
+        <p:spPr/>
+        <p:txBody>
+          <a:bodyPr/>
+          <a:lstStyle/>
+          <a:p>
+            <a:r>
+              <a:t>[~1 min 30] Le contexte du projet est celui d'un barbershop haut de gamme, fictif, qui souhaite exploiter ses photos de réalisations. Concrètement, il dispose de nombreuses images de coupes qu'il faut labéliser : on parle de styles comme le fade, l'afro, la tresse, le dégradé, ou encore la barbe. La problématique centrale est la suivante : comment collecter, labéliser et versionner toutes ces images, tout en garantissant une traçabilité complète des données jusqu'au modèle d'intelligence artificielle ?</a:t>
+            </a:r>
+          </a:p>
+          <a:p>
+            <a:r>
+              <a:t>C'est tout l'enjeu d'un pipeline de données bien structuré. On ne peut pas simplement jeter des images dans un dossier et lancer un entraînement : il faut savoir d'où vient chaque donnée, à quel stade elle se trouve, et avec quelle version du dataset le modèle a été entraîné. Tout au long de cette présentation, je vais suivre cette chaîne logique que vous voyez en bas de l'écran : ingestion, puis labélisation, puis versioning, puis entraînement, et enfin la recommandation côté client. Chaque étape de cette symphonie a son rôle, et c'est leur enchaînement maîtrisé qui fait la valeur du projet.</a:t>
+            </a:r>
+          </a:p>
+        </p:txBody>
+      </p:sp>
+      <p:sp>
+        <p:nvSpPr>
+          <p:cNvPr id="4" name="Slide Number Placeholder 3"/>
+          <p:cNvSpPr>
+            <a:spLocks noGrp="1"/>
+          </p:cNvSpPr>
+          <p:nvPr>
+            <p:ph type="sldNum" idx="5" sz="quarter"/>
+          </p:nvPr>
+        </p:nvSpPr>
+        <p:spPr/>
+      </p:sp>
+    </p:spTree>
+  </p:cSld>
+  <p:clrMapOvr>
+    <a:masterClrMapping/>
+  </p:clrMapOvr>
+</p:notes>
+</file>
+
+<file path=ppt/notesSlides/notesSlide3.xml><?xml version="1.0" encoding="utf-8"?>
+<p:notes xmlns:a="http://schemas.openxmlformats.org/drawingml/2006/main" xmlns:p="http://schemas.openxmlformats.org/presentationml/2006/main" xmlns:r="http://schemas.openxmlformats.org/officeDocument/2006/relationships">
+  <p:cSld>
+    <p:spTree>
+      <p:nvGrpSpPr>
+        <p:cNvPr id="1" name=""/>
+        <p:cNvGrpSpPr/>
+        <p:nvPr/>
+      </p:nvGrpSpPr>
+      <p:grpSpPr>
+        <a:xfrm>
+          <a:off x="0" y="0"/>
+          <a:ext cx="0" cy="0"/>
+          <a:chOff x="0" y="0"/>
+          <a:chExt cx="0" cy="0"/>
+        </a:xfrm>
+      </p:grpSpPr>
+      <p:sp>
+        <p:nvSpPr>
+          <p:cNvPr id="2" name="Slide Image Placeholder 1"/>
+          <p:cNvSpPr>
+            <a:spLocks noGrp="1"/>
+          </p:cNvSpPr>
+          <p:nvPr>
+            <p:ph type="sldImg" idx="2"/>
+          </p:nvPr>
+        </p:nvSpPr>
+        <p:spPr/>
+      </p:sp>
+      <p:sp>
+        <p:nvSpPr>
+          <p:cNvPr id="3" name="Notes Placeholder 2"/>
+          <p:cNvSpPr>
+            <a:spLocks noGrp="1"/>
+          </p:cNvSpPr>
+          <p:nvPr>
+            <p:ph type="body" idx="3" sz="quarter"/>
+          </p:nvPr>
+        </p:nvSpPr>
+        <p:spPr/>
+        <p:txBody>
+          <a:bodyPr/>
+          <a:lstStyle/>
+          <a:p>
+            <a:r>
+              <a:t>[~1 min 30] Voici la vue d'ensemble de l'architecture. Elle est organisée en couches bien distinctes. Tout en haut, le frontend en Angular 17, qui propose deux interfaces : une interface d'administration pour gérer les données, et une interface client pour la recommandation. Le frontend dialogue avec le backend NestJS via une API REST, sur le port 3001, avec des Guards JWT pour la sécurité et Multer pour la réception des fichiers.</a:t>
+            </a:r>
+          </a:p>
+          <a:p>
+            <a:r>
+              <a:t>Un point important de conception : le stockage est hybride. Les fichiers images, qui sont lourds, sont écrits directement sur le disque, dans le dossier uploads. En revanche, toutes les métadonnées — le statut, les labels, les caractéristiques — sont stockées dans MongoDB. Cette séparation est volontaire et je reviendrai dessus, car elle nous permettra plus tard de migrer vers le cloud sans rien casser.</a:t>
+            </a:r>
+          </a:p>
+          <a:p>
+            <a:r>
+              <a:t>Enfin, tout en bas, la partie Python avec scikit-learn : c'est le script train.py qui consomme le dataset exporté et produit le modèle, le fichier model.pkl. À noter qu'il y a deux usages de l'IA dans ce projet : un machine learning « offline » côté serveur pour l'entraînement, et un machine learning « in-browser », dans le navigateur, pour la recommandation client avec MediaPipe.</a:t>
+            </a:r>
+          </a:p>
+        </p:txBody>
+      </p:sp>
+      <p:sp>
+        <p:nvSpPr>
+          <p:cNvPr id="4" name="Slide Number Placeholder 3"/>
+          <p:cNvSpPr>
+            <a:spLocks noGrp="1"/>
+          </p:cNvSpPr>
+          <p:nvPr>
+            <p:ph type="sldNum" idx="5" sz="quarter"/>
+          </p:nvPr>
+        </p:nvSpPr>
+        <p:spPr/>
+      </p:sp>
+    </p:spTree>
+  </p:cSld>
+  <p:clrMapOvr>
+    <a:masterClrMapping/>
+  </p:clrMapOvr>
+</p:notes>
+</file>
+
+<file path=ppt/notesSlides/notesSlide4.xml><?xml version="1.0" encoding="utf-8"?>
+<p:notes xmlns:a="http://schemas.openxmlformats.org/drawingml/2006/main" xmlns:p="http://schemas.openxmlformats.org/presentationml/2006/main" xmlns:r="http://schemas.openxmlformats.org/officeDocument/2006/relationships">
+  <p:cSld>
+    <p:spTree>
+      <p:nvGrpSpPr>
+        <p:cNvPr id="1" name=""/>
+        <p:cNvGrpSpPr/>
+        <p:nvPr/>
+      </p:nvGrpSpPr>
+      <p:grpSpPr>
+        <a:xfrm>
+          <a:off x="0" y="0"/>
+          <a:ext cx="0" cy="0"/>
+          <a:chOff x="0" y="0"/>
+          <a:chExt cx="0" cy="0"/>
+        </a:xfrm>
+      </p:grpSpPr>
+      <p:sp>
+        <p:nvSpPr>
+          <p:cNvPr id="2" name="Slide Image Placeholder 1"/>
+          <p:cNvSpPr>
+            <a:spLocks noGrp="1"/>
+          </p:cNvSpPr>
+          <p:nvPr>
+            <p:ph type="sldImg" idx="2"/>
+          </p:nvPr>
+        </p:nvSpPr>
+        <p:spPr/>
+      </p:sp>
+      <p:sp>
+        <p:nvSpPr>
+          <p:cNvPr id="3" name="Notes Placeholder 2"/>
+          <p:cNvSpPr>
+            <a:spLocks noGrp="1"/>
+          </p:cNvSpPr>
+          <p:nvPr>
+            <p:ph type="body" idx="3" sz="quarter"/>
+          </p:nvPr>
+        </p:nvSpPr>
+        <p:spPr/>
+        <p:txBody>
+          <a:bodyPr/>
+          <a:lstStyle/>
+          <a:p>
+            <a:r>
+              <a:t>[~1 min] Rapidement sur la stack technique et surtout sur les raisons de ces choix. Angular 17 en mode standalone avec les signals pour une interface réactive et moderne. NestJS côté backend, pour son architecture modulaire qui sépare proprement les responsabilités. MongoDB pour la base de données : sa flexibilité de schéma est idéale pour des métadonnées hétérogènes, et ses agrégations natives sont parfaites pour calculer les statistiques de labels.</a:t>
+            </a:r>
+          </a:p>
+          <a:p>
+            <a:r>
+              <a:t>Pour l'extraction de caractéristiques, j'utilise sharp, une bibliothèque Node.js très légère. Côté machine learning, scikit-learn avec un RandomForest, qui est une valeur sûre pour un dataset de taille limitée. MediaPipe pour la détection de visage dans le navigateur. Et enfin, l'authentification combine du JWT classique avec une connexion Google via OAuth2. Chaque brique a été choisie pour une raison précise, pas par effet de mode.</a:t>
+            </a:r>
+          </a:p>
+        </p:txBody>
+      </p:sp>
+      <p:sp>
+        <p:nvSpPr>
+          <p:cNvPr id="4" name="Slide Number Placeholder 3"/>
+          <p:cNvSpPr>
+            <a:spLocks noGrp="1"/>
+          </p:cNvSpPr>
+          <p:nvPr>
+            <p:ph type="sldNum" idx="5" sz="quarter"/>
+          </p:nvPr>
+        </p:nvSpPr>
+        <p:spPr/>
+      </p:sp>
+    </p:spTree>
+  </p:cSld>
+  <p:clrMapOvr>
+    <a:masterClrMapping/>
+  </p:clrMapOvr>
+</p:notes>
+</file>
+
+<file path=ppt/notesSlides/notesSlide5.xml><?xml version="1.0" encoding="utf-8"?>
+<p:notes xmlns:a="http://schemas.openxmlformats.org/drawingml/2006/main" xmlns:p="http://schemas.openxmlformats.org/presentationml/2006/main" xmlns:r="http://schemas.openxmlformats.org/officeDocument/2006/relationships">
+  <p:cSld>
+    <p:spTree>
+      <p:nvGrpSpPr>
+        <p:cNvPr id="1" name=""/>
+        <p:cNvGrpSpPr/>
+        <p:nvPr/>
+      </p:nvGrpSpPr>
+      <p:grpSpPr>
+        <a:xfrm>
+          <a:off x="0" y="0"/>
+          <a:ext cx="0" cy="0"/>
+          <a:chOff x="0" y="0"/>
+          <a:chExt cx="0" cy="0"/>
+        </a:xfrm>
+      </p:grpSpPr>
+      <p:sp>
+        <p:nvSpPr>
+          <p:cNvPr id="2" name="Slide Image Placeholder 1"/>
+          <p:cNvSpPr>
+            <a:spLocks noGrp="1"/>
+          </p:cNvSpPr>
+          <p:nvPr>
+            <p:ph type="sldImg" idx="2"/>
+          </p:nvPr>
+        </p:nvSpPr>
+        <p:spPr/>
+      </p:sp>
+      <p:sp>
+        <p:nvSpPr>
+          <p:cNvPr id="3" name="Notes Placeholder 2"/>
+          <p:cNvSpPr>
+            <a:spLocks noGrp="1"/>
+          </p:cNvSpPr>
+          <p:nvPr>
+            <p:ph type="body" idx="3" sz="quarter"/>
+          </p:nvPr>
+        </p:nvSpPr>
+        <p:spPr/>
+        <p:txBody>
+          <a:bodyPr/>
+          <a:lstStyle/>
+          <a:p>
+            <a:r>
+              <a:t>[~1 min 30] Passons au schéma de la base de données. Il y a trois collections principales. La première, GalleryItem, représente chaque image : on y trouve son nom de fichier, son URL sur le disque, son statut dans le pipeline, ses labels, et surtout ses features, c'est-à-dire les caractéristiques numériques extraites automatiquement. La deuxième collection, DatasetVersion, représente un snapshot versionné : elle contient un numéro de version, le nombre d'images, la liste des identifiants d'images incluses et les labels concernés. Enfin, la collection User gère les comptes, avec le rôle client ou admin et la connexion Google.</a:t>
+            </a:r>
+          </a:p>
+          <a:p>
+            <a:r>
+              <a:t>La relation clé est celle que vous voyez au centre : le champ datasetVersion d'une image pointe vers la version d'un dataset. C'est une relation volontairement légère, typique d'une base documentaire. Pourquoi légère ? Parce que les snapshots sont immuables : une fois qu'une version est créée, elle ne change plus jamais. Il n'y a donc pas besoin de contraintes d'intégrité fortes comme dans une base relationnelle classique. Et je rappelle le principe hybride : les fichiers sont sur le disque, les métadonnées dans Mongo.</a:t>
+            </a:r>
+          </a:p>
+        </p:txBody>
+      </p:sp>
+      <p:sp>
+        <p:nvSpPr>
+          <p:cNvPr id="4" name="Slide Number Placeholder 3"/>
+          <p:cNvSpPr>
+            <a:spLocks noGrp="1"/>
+          </p:cNvSpPr>
+          <p:nvPr>
+            <p:ph type="sldNum" idx="5" sz="quarter"/>
+          </p:nvPr>
+        </p:nvSpPr>
+        <p:spPr/>
+      </p:sp>
+    </p:spTree>
+  </p:cSld>
+  <p:clrMapOvr>
+    <a:masterClrMapping/>
+  </p:clrMapOvr>
+</p:notes>
+</file>
+
+<file path=ppt/notesSlides/notesSlide6.xml><?xml version="1.0" encoding="utf-8"?>
+<p:notes xmlns:a="http://schemas.openxmlformats.org/drawingml/2006/main" xmlns:p="http://schemas.openxmlformats.org/presentationml/2006/main" xmlns:r="http://schemas.openxmlformats.org/officeDocument/2006/relationships">
+  <p:cSld>
+    <p:spTree>
+      <p:nvGrpSpPr>
+        <p:cNvPr id="1" name=""/>
+        <p:cNvGrpSpPr/>
+        <p:nvPr/>
+      </p:nvGrpSpPr>
+      <p:grpSpPr>
+        <a:xfrm>
+          <a:off x="0" y="0"/>
+          <a:ext cx="0" cy="0"/>
+          <a:chOff x="0" y="0"/>
+          <a:chExt cx="0" cy="0"/>
+        </a:xfrm>
+      </p:grpSpPr>
+      <p:sp>
+        <p:nvSpPr>
+          <p:cNvPr id="2" name="Slide Image Placeholder 1"/>
+          <p:cNvSpPr>
+            <a:spLocks noGrp="1"/>
+          </p:cNvSpPr>
+          <p:nvPr>
+            <p:ph type="sldImg" idx="2"/>
+          </p:nvPr>
+        </p:nvSpPr>
+        <p:spPr/>
+      </p:sp>
+      <p:sp>
+        <p:nvSpPr>
+          <p:cNvPr id="3" name="Notes Placeholder 2"/>
+          <p:cNvSpPr>
+            <a:spLocks noGrp="1"/>
+          </p:cNvSpPr>
+          <p:nvPr>
+            <p:ph type="body" idx="3" sz="quarter"/>
+          </p:nvPr>
+        </p:nvSpPr>
+        <p:spPr/>
+        <p:txBody>
+          <a:bodyPr/>
+          <a:lstStyle/>
+          <a:p>
+            <a:r>
+              <a:t>[~1 min 30] Le cœur du projet, c'est ce pipeline de données en cinq statuts. Une image traverse ces étapes dans un seul sens, du début à la fin. Première étape, RAW : l'image vient d'être uploadée. NestJS et Multer la sauvegardent, et sharp en extrait automatiquement les caractéristiques. À ce stade, rien d'humain n'est intervenu sur le contenu. Deuxième étape, VALIDATED : un administrateur vérifie visuellement la qualité — le cadrage, la netteté, la pertinence de l'image.</a:t>
+            </a:r>
+          </a:p>
+          <a:p>
+            <a:r>
+              <a:t>Troisième étape, LABELED : c'est l'étape de labélisation manuelle, où l'admin assigne de un à plusieurs labels parmi les douze disponibles. Quatrième étape, PROCESSED : validation finale, l'image est jugée complète et prête. Et enfin EXPORTED : l'image est intégrée dans un snapshot versionné.</a:t>
+            </a:r>
+          </a:p>
+          <a:p>
+            <a:r>
+              <a:t>Le point essentiel ici, c'est que les transitions sont unidirectionnelles : on ne revient jamais en arrière. Cela garantit la traçabilité. Et seules les images suffisamment avancées dans le pipeline sont éligibles à un dataset. Un funnel visuel permet à l'administrateur de voir, en un coup d'œil, combien d'images sont à chaque étape et où se trouvent les goulots d'étranglement.</a:t>
+            </a:r>
+          </a:p>
+        </p:txBody>
+      </p:sp>
+      <p:sp>
+        <p:nvSpPr>
+          <p:cNvPr id="4" name="Slide Number Placeholder 3"/>
+          <p:cNvSpPr>
+            <a:spLocks noGrp="1"/>
+          </p:cNvSpPr>
+          <p:nvPr>
+            <p:ph type="sldNum" idx="5" sz="quarter"/>
+          </p:nvPr>
+        </p:nvSpPr>
+        <p:spPr/>
+      </p:sp>
+    </p:spTree>
+  </p:cSld>
+  <p:clrMapOvr>
+    <a:masterClrMapping/>
+  </p:clrMapOvr>
+</p:notes>
+</file>
+
+<file path=ppt/notesSlides/notesSlide7.xml><?xml version="1.0" encoding="utf-8"?>
+<p:notes xmlns:a="http://schemas.openxmlformats.org/drawingml/2006/main" xmlns:p="http://schemas.openxmlformats.org/presentationml/2006/main" xmlns:r="http://schemas.openxmlformats.org/officeDocument/2006/relationships">
+  <p:cSld>
+    <p:spTree>
+      <p:nvGrpSpPr>
+        <p:cNvPr id="1" name=""/>
+        <p:cNvGrpSpPr/>
+        <p:nvPr/>
+      </p:nvGrpSpPr>
+      <p:grpSpPr>
+        <a:xfrm>
+          <a:off x="0" y="0"/>
+          <a:ext cx="0" cy="0"/>
+          <a:chOff x="0" y="0"/>
+          <a:chExt cx="0" cy="0"/>
+        </a:xfrm>
+      </p:grpSpPr>
+      <p:sp>
+        <p:nvSpPr>
+          <p:cNvPr id="2" name="Slide Image Placeholder 1"/>
+          <p:cNvSpPr>
+            <a:spLocks noGrp="1"/>
+          </p:cNvSpPr>
+          <p:nvPr>
+            <p:ph type="sldImg" idx="2"/>
+          </p:nvPr>
+        </p:nvSpPr>
+        <p:spPr/>
+      </p:sp>
+      <p:sp>
+        <p:nvSpPr>
+          <p:cNvPr id="3" name="Notes Placeholder 2"/>
+          <p:cNvSpPr>
+            <a:spLocks noGrp="1"/>
+          </p:cNvSpPr>
+          <p:nvPr>
+            <p:ph type="body" idx="3" sz="quarter"/>
+          </p:nvPr>
+        </p:nvSpPr>
+        <p:spPr/>
+        <p:txBody>
+          <a:bodyPr/>
+          <a:lstStyle/>
+          <a:p>
+            <a:r>
+              <a:t>[~1 min] Revenons sur l'extraction de features, car c'est ce qui alimente le modèle. À chaque upload, de manière totalement automatique et transparente pour l'administrateur, sharp calcule un vecteur de sept caractéristiques numériques. Vous les voyez à l'écran : la largeur et la hauteur en pixels, la taille du fichier, le ratio largeur sur hauteur, et les trois composantes rouge, vert, bleu de la couleur dominante de l'image.</a:t>
+            </a:r>
+          </a:p>
+          <a:p>
+            <a:r>
+              <a:t>Ce vecteur de dimension sept est immédiatement stocké dans MongoDB, aux côtés de l'image. L'avantage est double : d'une part, le calcul est fait une seule fois, à l'upload ; d'autre part, ce vecteur est directement réutilisable par le script Python d'entraînement, sans aucun retraitement. La donnée est prête à servir au modèle dès qu'elle entre dans le système.</a:t>
+            </a:r>
+          </a:p>
+        </p:txBody>
+      </p:sp>
+      <p:sp>
+        <p:nvSpPr>
+          <p:cNvPr id="4" name="Slide Number Placeholder 3"/>
+          <p:cNvSpPr>
+            <a:spLocks noGrp="1"/>
+          </p:cNvSpPr>
+          <p:nvPr>
+            <p:ph type="sldNum" idx="5" sz="quarter"/>
+          </p:nvPr>
+        </p:nvSpPr>
+        <p:spPr/>
+      </p:sp>
+    </p:spTree>
+  </p:cSld>
+  <p:clrMapOvr>
+    <a:masterClrMapping/>
+  </p:clrMapOvr>
+</p:notes>
+</file>
+
+<file path=ppt/notesSlides/notesSlide8.xml><?xml version="1.0" encoding="utf-8"?>
+<p:notes xmlns:a="http://schemas.openxmlformats.org/drawingml/2006/main" xmlns:p="http://schemas.openxmlformats.org/presentationml/2006/main" xmlns:r="http://schemas.openxmlformats.org/officeDocument/2006/relationships">
+  <p:cSld>
+    <p:spTree>
+      <p:nvGrpSpPr>
+        <p:cNvPr id="1" name=""/>
+        <p:cNvGrpSpPr/>
+        <p:nvPr/>
+      </p:nvGrpSpPr>
+      <p:grpSpPr>
+        <a:xfrm>
+          <a:off x="0" y="0"/>
+          <a:ext cx="0" cy="0"/>
+          <a:chOff x="0" y="0"/>
+          <a:chExt cx="0" cy="0"/>
+        </a:xfrm>
+      </p:grpSpPr>
+      <p:sp>
+        <p:nvSpPr>
+          <p:cNvPr id="2" name="Slide Image Placeholder 1"/>
+          <p:cNvSpPr>
+            <a:spLocks noGrp="1"/>
+          </p:cNvSpPr>
+          <p:nvPr>
+            <p:ph type="sldImg" idx="2"/>
+          </p:nvPr>
+        </p:nvSpPr>
+        <p:spPr/>
+      </p:sp>
+      <p:sp>
+        <p:nvSpPr>
+          <p:cNvPr id="3" name="Notes Placeholder 2"/>
+          <p:cNvSpPr>
+            <a:spLocks noGrp="1"/>
+          </p:cNvSpPr>
+          <p:nvPr>
+            <p:ph type="body" idx="3" sz="quarter"/>
+          </p:nvPr>
+        </p:nvSpPr>
+        <p:spPr/>
+        <p:txBody>
+          <a:bodyPr/>
+          <a:lstStyle/>
+          <a:p>
+            <a:r>
+              <a:t>[~1 min 30] Le versioning des datasets est une exigence forte du projet, et c'est un concept clé en machine learning. Le principe : un snapshot immuable. À un instant donné, l'administrateur clique sur « Créer une version ». Le backend identifie automatiquement toutes les images éligibles, c'est-à-dire celles qui sont labélisées, traitées ou déjà exportées. Il crée alors un document DatasetVersion qui fige la liste exacte des images et des labels. Enfin, ces images reçoivent le tag de la version.</a:t>
+            </a:r>
+          </a:p>
+          <a:p>
+            <a:r>
+              <a:t>Pourquoi est-ce si important ? Parce que cela garantit la reproductibilité. Si je relance l'entraînement sur la version 1 dans six mois, j'obtiendrai exactement le même modèle, car les données n'auront pas bougé d'un pixel. C'est fondamental pour pouvoir auditer un modèle, comparer deux versions, ou comprendre une régression de performance. Les versions sont numérotées, horodatées, et conservées dans l'historique. Cette contrainte du sujet — le versioning immuable — est donc pleinement respectée.</a:t>
+            </a:r>
+          </a:p>
+        </p:txBody>
+      </p:sp>
+      <p:sp>
+        <p:nvSpPr>
+          <p:cNvPr id="4" name="Slide Number Placeholder 3"/>
+          <p:cNvSpPr>
+            <a:spLocks noGrp="1"/>
+          </p:cNvSpPr>
+          <p:nvPr>
+            <p:ph type="sldNum" idx="5" sz="quarter"/>
+          </p:nvPr>
+        </p:nvSpPr>
+        <p:spPr/>
+      </p:sp>
+    </p:spTree>
+  </p:cSld>
+  <p:clrMapOvr>
+    <a:masterClrMapping/>
+  </p:clrMapOvr>
+</p:notes>
+</file>
+
+<file path=ppt/notesSlides/notesSlide9.xml><?xml version="1.0" encoding="utf-8"?>
+<p:notes xmlns:a="http://schemas.openxmlformats.org/drawingml/2006/main" xmlns:p="http://schemas.openxmlformats.org/presentationml/2006/main" xmlns:r="http://schemas.openxmlformats.org/officeDocument/2006/relationships">
+  <p:cSld>
+    <p:spTree>
+      <p:nvGrpSpPr>
+        <p:cNvPr id="1" name=""/>
+        <p:cNvGrpSpPr/>
+        <p:nvPr/>
+      </p:nvGrpSpPr>
+      <p:grpSpPr>
+        <a:xfrm>
+          <a:off x="0" y="0"/>
+          <a:ext cx="0" cy="0"/>
+          <a:chOff x="0" y="0"/>
+          <a:chExt cx="0" cy="0"/>
+        </a:xfrm>
+      </p:grpSpPr>
+      <p:sp>
+        <p:nvSpPr>
+          <p:cNvPr id="2" name="Slide Image Placeholder 1"/>
+          <p:cNvSpPr>
+            <a:spLocks noGrp="1"/>
+          </p:cNvSpPr>
+          <p:nvPr>
+            <p:ph type="sldImg" idx="2"/>
+          </p:nvPr>
+        </p:nvSpPr>
+        <p:spPr/>
+      </p:sp>
+      <p:sp>
+        <p:nvSpPr>
+          <p:cNvPr id="3" name="Notes Placeholder 2"/>
+          <p:cNvSpPr>
+            <a:spLocks noGrp="1"/>
+          </p:cNvSpPr>
+          <p:nvPr>
+            <p:ph type="body" idx="3" sz="quarter"/>
+          </p:nvPr>
+        </p:nvSpPr>
+        <p:spPr/>
+        <p:txBody>
+          <a:bodyPr/>
+          <a:lstStyle/>
+          <a:p>
+            <a:r>
+              <a:t>[~1 min 30] Venons-en à l'entraînement du modèle, dans le script train.py. La chaîne, que vous voyez à gauche, est la suivante : on charge le dataset JSON, on reconstruit le vecteur de features pour chaque image, on transforme les labels avec un MultiLabelBinarizer, on découpe en jeu d'entraînement et jeu de test selon un ratio 80/20, on entraîne le modèle, on évalue, et on sauvegarde dans model.pkl.</a:t>
+            </a:r>
+          </a:p>
+          <a:p>
+            <a:r>
+              <a:t>Le choix d'algorithme est important. C'est un problème multi-label : une même image peut porter plusieurs étiquettes en même temps, par exemple fade, plus barbe, plus adulte. J'utilise donc une stratégie OneVsRest par-dessus un RandomForest : concrètement, on entraîne un classifieur indépendant par label, ce qui permet de prédire plusieurs labels simultanément. Côté paramètres, cent arbres dans la forêt, un split 80/20, et un random_state fixé à 42 pour garantir la reproductibilité. Le lancement est très simple : une seule commande, py train.py, suivie du fichier dataset, et le modèle est produit.</a:t>
+            </a:r>
+          </a:p>
+        </p:txBody>
+      </p:sp>
+      <p:sp>
+        <p:nvSpPr>
+          <p:cNvPr id="4" name="Slide Number Placeholder 3"/>
+          <p:cNvSpPr>
+            <a:spLocks noGrp="1"/>
+          </p:cNvSpPr>
+          <p:nvPr>
+            <p:ph type="sldNum" idx="5" sz="quarter"/>
+          </p:nvPr>
+        </p:nvSpPr>
+        <p:spPr/>
+      </p:sp>
+    </p:spTree>
+  </p:cSld>
+  <p:clrMapOvr>
+    <a:masterClrMapping/>
+  </p:clrMapOvr>
+</p:notes>
 </file>
 
 <file path=ppt/slideLayouts/slideLayout1.xml><?xml version="1.0" encoding="utf-8"?>
@@ -9923,4 +11253,324 @@
   </a:objectDefaults>
   <a:extraClrSchemeLst/>
 </a:theme>
+</file>
+
+<file path=ppt/theme/theme2.xml><?xml version="1.0" encoding="utf-8"?>
+<a:theme xmlns:a="http://schemas.openxmlformats.org/drawingml/2006/main" name="Office Theme">
+  <a:themeElements>
+    <a:clrScheme name="Office">
+      <a:dk1>
+        <a:sysClr val="windowText" lastClr="000000"/>
+      </a:dk1>
+      <a:lt1>
+        <a:sysClr val="window" lastClr="FFFFFF"/>
+      </a:lt1>
+      <a:dk2>
+        <a:srgbClr val="1F497D"/>
+      </a:dk2>
+      <a:lt2>
+        <a:srgbClr val="EEECE1"/>
+      </a:lt2>
+      <a:accent1>
+        <a:srgbClr val="4F81BD"/>
+      </a:accent1>
+      <a:accent2>
+        <a:srgbClr val="C0504D"/>
+      </a:accent2>
+      <a:accent3>
+        <a:srgbClr val="9BBB59"/>
+      </a:accent3>
+      <a:accent4>
+        <a:srgbClr val="8064A2"/>
+      </a:accent4>
+      <a:accent5>
+        <a:srgbClr val="4BACC6"/>
+      </a:accent5>
+      <a:accent6>
+        <a:srgbClr val="F79646"/>
+      </a:accent6>
+      <a:hlink>
+        <a:srgbClr val="0000FF"/>
+      </a:hlink>
+      <a:folHlink>
+        <a:srgbClr val="800080"/>
+      </a:folHlink>
+    </a:clrScheme>
+    <a:fontScheme name="Office">
+      <a:majorFont>
+        <a:latin typeface="Calibri"/>
+        <a:ea typeface=""/>
+        <a:cs typeface=""/>
+        <a:font script="Jpan" typeface="ＭＳ Ｐゴシック"/>
+        <a:font script="Hang" typeface="맑은 고딕"/>
+        <a:font script="Hans" typeface="宋体"/>
+        <a:font script="Hant" typeface="新細明體"/>
+        <a:font script="Arab" typeface="Times New Roman"/>
+        <a:font script="Hebr" typeface="Times New Roman"/>
+        <a:font script="Thai" typeface="Angsana New"/>
+        <a:font script="Ethi" typeface="Nyala"/>
+        <a:font script="Beng" typeface="Vrinda"/>
+        <a:font script="Gujr" typeface="Shruti"/>
+        <a:font script="Khmr" typeface="MoolBoran"/>
+        <a:font script="Knda" typeface="Tunga"/>
+        <a:font script="Guru" typeface="Raavi"/>
+        <a:font script="Cans" typeface="Euphemia"/>
+        <a:font script="Cher" typeface="Plantagenet Cherokee"/>
+        <a:font script="Yiii" typeface="Microsoft Yi Baiti"/>
+        <a:font script="Tibt" typeface="Microsoft Himalaya"/>
+        <a:font script="Thaa" typeface="MV Boli"/>
+        <a:font script="Deva" typeface="Mangal"/>
+        <a:font script="Telu" typeface="Gautami"/>
+        <a:font script="Taml" typeface="Latha"/>
+        <a:font script="Syrc" typeface="Estrangelo Edessa"/>
+        <a:font script="Orya" typeface="Kalinga"/>
+        <a:font script="Mlym" typeface="Kartika"/>
+        <a:font script="Laoo" typeface="DokChampa"/>
+        <a:font script="Sinh" typeface="Iskoola Pota"/>
+        <a:font script="Mong" typeface="Mongolian Baiti"/>
+        <a:font script="Viet" typeface="Times New Roman"/>
+        <a:font script="Uigh" typeface="Microsoft Uighur"/>
+        <a:font script="Geor" typeface="Sylfaen"/>
+      </a:majorFont>
+      <a:minorFont>
+        <a:latin typeface="Calibri"/>
+        <a:ea typeface=""/>
+        <a:cs typeface=""/>
+        <a:font script="Jpan" typeface="ＭＳ Ｐゴシック"/>
+        <a:font script="Hang" typeface="맑은 고딕"/>
+        <a:font script="Hans" typeface="宋体"/>
+        <a:font script="Hant" typeface="新細明體"/>
+        <a:font script="Arab" typeface="Arial"/>
+        <a:font script="Hebr" typeface="Arial"/>
+        <a:font script="Thai" typeface="Cordia New"/>
+        <a:font script="Ethi" typeface="Nyala"/>
+        <a:font script="Beng" typeface="Vrinda"/>
+        <a:font script="Gujr" typeface="Shruti"/>
+        <a:font script="Khmr" typeface="DaunPenh"/>
+        <a:font script="Knda" typeface="Tunga"/>
+        <a:font script="Guru" typeface="Raavi"/>
+        <a:font script="Cans" typeface="Euphemia"/>
+        <a:font script="Cher" typeface="Plantagenet Cherokee"/>
+        <a:font script="Yiii" typeface="Microsoft Yi Baiti"/>
+        <a:font script="Tibt" typeface="Microsoft Himalaya"/>
+        <a:font script="Thaa" typeface="MV Boli"/>
+        <a:font script="Deva" typeface="Mangal"/>
+        <a:font script="Telu" typeface="Gautami"/>
+        <a:font script="Taml" typeface="Latha"/>
+        <a:font script="Syrc" typeface="Estrangelo Edessa"/>
+        <a:font script="Orya" typeface="Kalinga"/>
+        <a:font script="Mlym" typeface="Kartika"/>
+        <a:font script="Laoo" typeface="DokChampa"/>
+        <a:font script="Sinh" typeface="Iskoola Pota"/>
+        <a:font script="Mong" typeface="Mongolian Baiti"/>
+        <a:font script="Viet" typeface="Arial"/>
+        <a:font script="Uigh" typeface="Microsoft Uighur"/>
+        <a:font script="Geor" typeface="Sylfaen"/>
+      </a:minorFont>
+    </a:fontScheme>
+    <a:fmtScheme name="Office">
+      <a:fillStyleLst>
+        <a:solidFill>
+          <a:schemeClr val="phClr"/>
+        </a:solidFill>
+        <a:gradFill rotWithShape="1">
+          <a:gsLst>
+            <a:gs pos="0">
+              <a:schemeClr val="phClr">
+                <a:tint val="50000"/>
+                <a:satMod val="300000"/>
+              </a:schemeClr>
+            </a:gs>
+            <a:gs pos="35000">
+              <a:schemeClr val="phClr">
+                <a:tint val="37000"/>
+                <a:satMod val="300000"/>
+              </a:schemeClr>
+            </a:gs>
+            <a:gs pos="100000">
+              <a:schemeClr val="phClr">
+                <a:tint val="15000"/>
+                <a:satMod val="350000"/>
+              </a:schemeClr>
+            </a:gs>
+          </a:gsLst>
+          <a:lin ang="16200000" scaled="1"/>
+        </a:gradFill>
+        <a:gradFill rotWithShape="1">
+          <a:gsLst>
+            <a:gs pos="0">
+              <a:schemeClr val="phClr">
+                <a:tint val="100000"/>
+                <a:shade val="100000"/>
+                <a:satMod val="130000"/>
+              </a:schemeClr>
+            </a:gs>
+            <a:gs pos="100000">
+              <a:schemeClr val="phClr">
+                <a:tint val="50000"/>
+                <a:shade val="100000"/>
+                <a:satMod val="350000"/>
+              </a:schemeClr>
+            </a:gs>
+          </a:gsLst>
+          <a:lin ang="16200000" scaled="0"/>
+        </a:gradFill>
+      </a:fillStyleLst>
+      <a:lnStyleLst>
+        <a:ln w="9525" cap="flat" cmpd="sng" algn="ctr">
+          <a:solidFill>
+            <a:schemeClr val="phClr">
+              <a:shade val="95000"/>
+              <a:satMod val="105000"/>
+            </a:schemeClr>
+          </a:solidFill>
+          <a:prstDash val="solid"/>
+        </a:ln>
+        <a:ln w="25400" cap="flat" cmpd="sng" algn="ctr">
+          <a:solidFill>
+            <a:schemeClr val="phClr"/>
+          </a:solidFill>
+          <a:prstDash val="solid"/>
+        </a:ln>
+        <a:ln w="38100" cap="flat" cmpd="sng" algn="ctr">
+          <a:solidFill>
+            <a:schemeClr val="phClr"/>
+          </a:solidFill>
+          <a:prstDash val="solid"/>
+        </a:ln>
+      </a:lnStyleLst>
+      <a:effectStyleLst>
+        <a:effectStyle>
+          <a:effectLst>
+            <a:outerShdw blurRad="40000" dist="20000" dir="5400000" rotWithShape="0">
+              <a:srgbClr val="000000">
+                <a:alpha val="38000"/>
+              </a:srgbClr>
+            </a:outerShdw>
+          </a:effectLst>
+        </a:effectStyle>
+        <a:effectStyle>
+          <a:effectLst>
+            <a:outerShdw blurRad="40000" dist="23000" dir="5400000" rotWithShape="0">
+              <a:srgbClr val="000000">
+                <a:alpha val="35000"/>
+              </a:srgbClr>
+            </a:outerShdw>
+          </a:effectLst>
+        </a:effectStyle>
+        <a:effectStyle>
+          <a:effectLst>
+            <a:outerShdw blurRad="40000" dist="23000" dir="5400000" rotWithShape="0">
+              <a:srgbClr val="000000">
+                <a:alpha val="35000"/>
+              </a:srgbClr>
+            </a:outerShdw>
+          </a:effectLst>
+          <a:scene3d>
+            <a:camera prst="orthographicFront">
+              <a:rot lat="0" lon="0" rev="0"/>
+            </a:camera>
+            <a:lightRig rig="threePt" dir="t">
+              <a:rot lat="0" lon="0" rev="1200000"/>
+            </a:lightRig>
+          </a:scene3d>
+          <a:sp3d>
+            <a:bevelT w="63500" h="25400"/>
+          </a:sp3d>
+        </a:effectStyle>
+      </a:effectStyleLst>
+      <a:bgFillStyleLst>
+        <a:solidFill>
+          <a:schemeClr val="phClr"/>
+        </a:solidFill>
+        <a:gradFill rotWithShape="1">
+          <a:gsLst>
+            <a:gs pos="0">
+              <a:schemeClr val="phClr">
+                <a:tint val="40000"/>
+                <a:satMod val="350000"/>
+              </a:schemeClr>
+            </a:gs>
+            <a:gs pos="40000">
+              <a:schemeClr val="phClr">
+                <a:tint val="45000"/>
+                <a:shade val="99000"/>
+                <a:satMod val="350000"/>
+              </a:schemeClr>
+            </a:gs>
+            <a:gs pos="100000">
+              <a:schemeClr val="phClr">
+                <a:shade val="20000"/>
+                <a:satMod val="255000"/>
+              </a:schemeClr>
+            </a:gs>
+          </a:gsLst>
+          <a:path path="circle">
+            <a:fillToRect l="50000" t="-80000" r="50000" b="180000"/>
+          </a:path>
+        </a:gradFill>
+        <a:gradFill rotWithShape="1">
+          <a:gsLst>
+            <a:gs pos="0">
+              <a:schemeClr val="phClr">
+                <a:tint val="80000"/>
+                <a:satMod val="300000"/>
+              </a:schemeClr>
+            </a:gs>
+            <a:gs pos="100000">
+              <a:schemeClr val="phClr">
+                <a:shade val="30000"/>
+                <a:satMod val="200000"/>
+              </a:schemeClr>
+            </a:gs>
+          </a:gsLst>
+          <a:path path="circle">
+            <a:fillToRect l="50000" t="50000" r="50000" b="50000"/>
+          </a:path>
+        </a:gradFill>
+      </a:bgFillStyleLst>
+    </a:fmtScheme>
+  </a:themeElements>
+  <a:objectDefaults>
+    <a:spDef>
+      <a:spPr/>
+      <a:bodyPr/>
+      <a:lstStyle/>
+      <a:style>
+        <a:lnRef idx="1">
+          <a:schemeClr val="accent1"/>
+        </a:lnRef>
+        <a:fillRef idx="3">
+          <a:schemeClr val="accent1"/>
+        </a:fillRef>
+        <a:effectRef idx="2">
+          <a:schemeClr val="accent1"/>
+        </a:effectRef>
+        <a:fontRef idx="minor">
+          <a:schemeClr val="lt1"/>
+        </a:fontRef>
+      </a:style>
+    </a:spDef>
+    <a:lnDef>
+      <a:spPr/>
+      <a:bodyPr/>
+      <a:lstStyle/>
+      <a:style>
+        <a:lnRef idx="2">
+          <a:schemeClr val="accent1"/>
+        </a:lnRef>
+        <a:fillRef idx="0">
+          <a:schemeClr val="accent1"/>
+        </a:fillRef>
+        <a:effectRef idx="1">
+          <a:schemeClr val="accent1"/>
+        </a:effectRef>
+        <a:fontRef idx="minor">
+          <a:schemeClr val="tx1"/>
+        </a:fontRef>
+      </a:style>
+    </a:lnDef>
+  </a:objectDefaults>
+  <a:extraClrSchemeLst/>
+</a:theme>
 </file>
</xml_diff>